<commit_message>
Day 17/19 live diagrams + AWS services reference, plus pending Day 14/15/week3 updates
- Day 17: SSRF -> instance metadata -> stolen IAM creds -> cloud takeover sequence
  diagram (archify), and a security-lens AWS services reference (teacher.md).
- Day 19: Cyber Kill Chain <-> pentest lifecycle <-> Blue team correlation workflow
  diagram (archify), wired into day19.md as a new "One map, two ends" slide, with a
  matching ATT&CK cross-reference and live-alert framing tip in teacher-notes.md.
- Carries forward in-progress Day 14/15 and Week 3 edits, the Week 3 assignment
  handout, and a Day 1 theme experiment that were already in the working tree.

Co-Authored-By: Claude Sonnet 5 <noreply@anthropic.com>
</commit_message>
<xml_diff>
--- a/lessons-v2/day15/day15.pptx
+++ b/lessons-v2/day15/day15.pptx
@@ -1330,8 +1330,10 @@
           <a:p>
             <a:r>
               <a:rPr lang="en-US" dirty="0"/>
-              <a:t>Walk each part ~3 min. Part A = today's exercise, done solo, written properly. Part B is the
-"understand the exploit, don't just run it" stretch. Emphasise: reproducible commands, captioned
+              <a:t>Walk each part ~3 min. The loop is the point: learn the attack, find it with a scanner, prove it,
+fix it, prove the fix. Part B reuses the Day 14 findings table (their homework). Part C: at least
+two proofs must come from the Hacksplaining five so the theory shows up in the lab. Part D is the
+defensive half -- do not let anyone skip it. Emphasise: reproducible commands, captioned
 evidence, and STAY IN SCOPE.</a:t>
             </a:r>
             <a:endParaRPr lang="en-US" dirty="0"/>

</xml_diff>